<commit_message>
Redesenho editorial da apresentação enviável (V3k)
Pedido do sócio: visual mais requintado, sem aspecto de IA. Sistema
editorial de casa de consultoria: fundo branco, Cambria para display,
versaletes dourados, numerais serifados grandes, filetes no lugar de
cartões, árvore em arte de linha na capa, rodapé com paginação.
Mesmo conteúdo da v3. QA visual + PASS no Revisor nos dois documentos.

Co-Authored-By: Claude Fable 5 <noreply@anthropic.com>
Claude-Session: https://claude.ai/code/session_016RZJT8nVEB7u33HvjY5KvZ
</commit_message>
<xml_diff>
--- a/08-materiais/modelos/abba-um-minuto.pptx
+++ b/08-materiais/modelos/abba-um-minuto.pptx
@@ -857,7 +857,7 @@
     <p:bg>
       <p:bgPr>
         <a:solidFill>
-          <a:srgbClr val="1B2A4A"/>
+          <a:srgbClr val="FFFFFF"/>
         </a:solidFill>
       </p:bgPr>
     </p:bg>
@@ -877,21 +877,100 @@
       </p:grpSpPr>
       <p:sp>
         <p:nvSpPr>
-          <p:cNvPr id="2" name="Shape 0"/>
-          <p:cNvSpPr/>
-          <p:nvPr/>
-        </p:nvSpPr>
-        <p:spPr>
-          <a:xfrm>
-            <a:off x="8595360" y="-1737360"/>
-            <a:ext cx="4937760" cy="4937760"/>
-          </a:xfrm>
-          <a:prstGeom prst="ellipse">
-            <a:avLst/>
-          </a:prstGeom>
-          <a:ln w="12700">
+          <p:cNvPr id="2" name="Text 0"/>
+          <p:cNvSpPr/>
+          <p:nvPr/>
+        </p:nvSpPr>
+        <p:spPr>
+          <a:xfrm>
+            <a:off x="777240" y="685800"/>
+            <a:ext cx="1828800" cy="292608"/>
+          </a:xfrm>
+          <a:prstGeom prst="rect">
+            <a:avLst/>
+          </a:prstGeom>
+          <a:noFill/>
+          <a:ln/>
+        </p:spPr>
+        <p:txBody>
+          <a:bodyPr wrap="square" lIns="0" tIns="0" rIns="0" bIns="0" rtlCol="0" anchor="ctr"/>
+          <a:lstStyle/>
+          <a:p>
+            <a:pPr indent="0" marL="0">
+              <a:buNone/>
+            </a:pPr>
+            <a:r>
+              <a:rPr lang="en-US" sz="1300" b="1" spc="500" kern="0" dirty="0">
+                <a:solidFill>
+                  <a:srgbClr val="1B2A4A"/>
+                </a:solidFill>
+                <a:latin typeface="Calibri" pitchFamily="34" charset="0"/>
+                <a:ea typeface="Calibri" pitchFamily="34" charset="-122"/>
+                <a:cs typeface="Calibri" pitchFamily="34" charset="-120"/>
+              </a:rPr>
+              <a:t>ABBA</a:t>
+            </a:r>
+            <a:endParaRPr lang="en-US" sz="1300" dirty="0"/>
+          </a:p>
+        </p:txBody>
+      </p:sp>
+      <p:sp>
+        <p:nvSpPr>
+          <p:cNvPr id="3" name="Text 1"/>
+          <p:cNvSpPr/>
+          <p:nvPr/>
+        </p:nvSpPr>
+        <p:spPr>
+          <a:xfrm>
+            <a:off x="777240" y="969264"/>
+            <a:ext cx="4114800" cy="201168"/>
+          </a:xfrm>
+          <a:prstGeom prst="rect">
+            <a:avLst/>
+          </a:prstGeom>
+          <a:noFill/>
+          <a:ln/>
+        </p:spPr>
+        <p:txBody>
+          <a:bodyPr wrap="square" lIns="0" tIns="0" rIns="0" bIns="0" rtlCol="0" anchor="ctr"/>
+          <a:lstStyle/>
+          <a:p>
+            <a:pPr indent="0" marL="0">
+              <a:buNone/>
+            </a:pPr>
+            <a:r>
+              <a:rPr lang="en-US" sz="800" spc="260" kern="0" dirty="0">
+                <a:solidFill>
+                  <a:srgbClr val="5A6472"/>
+                </a:solidFill>
+                <a:latin typeface="Calibri" pitchFamily="34" charset="0"/>
+                <a:ea typeface="Calibri" pitchFamily="34" charset="-122"/>
+                <a:cs typeface="Calibri" pitchFamily="34" charset="-120"/>
+              </a:rPr>
+              <a:t>CONSULTORIA DE INTELIGÊNCIA ARTIFICIAL</a:t>
+            </a:r>
+            <a:endParaRPr lang="en-US" sz="800" dirty="0"/>
+          </a:p>
+        </p:txBody>
+      </p:sp>
+      <p:sp>
+        <p:nvSpPr>
+          <p:cNvPr id="4" name="Shape 2"/>
+          <p:cNvSpPr/>
+          <p:nvPr/>
+        </p:nvSpPr>
+        <p:spPr>
+          <a:xfrm>
+            <a:off x="6537960" y="907085"/>
+            <a:ext cx="0" cy="1020470"/>
+          </a:xfrm>
+          <a:prstGeom prst="line">
+            <a:avLst/>
+          </a:prstGeom>
+          <a:noFill/>
+          <a:ln w="17780">
             <a:solidFill>
-              <a:srgbClr val="C2A35B"/>
+              <a:srgbClr val="B8985A"/>
             </a:solidFill>
             <a:prstDash val="solid"/>
           </a:ln>
@@ -899,14 +978,221 @@
       </p:sp>
       <p:sp>
         <p:nvSpPr>
-          <p:cNvPr id="3" name="Text 1"/>
-          <p:cNvSpPr/>
-          <p:nvPr/>
-        </p:nvSpPr>
-        <p:spPr>
-          <a:xfrm>
-            <a:off x="548640" y="457200"/>
-            <a:ext cx="2743200" cy="320040"/>
+          <p:cNvPr id="5" name="Shape 3"/>
+          <p:cNvSpPr/>
+          <p:nvPr/>
+        </p:nvSpPr>
+        <p:spPr>
+          <a:xfrm flipV="1">
+            <a:off x="6537960" y="1105510"/>
+            <a:ext cx="-311810" cy="-340157"/>
+          </a:xfrm>
+          <a:prstGeom prst="line">
+            <a:avLst/>
+          </a:prstGeom>
+          <a:noFill/>
+          <a:ln w="13970">
+            <a:solidFill>
+              <a:srgbClr val="B8985A"/>
+            </a:solidFill>
+            <a:prstDash val="solid"/>
+          </a:ln>
+        </p:spPr>
+      </p:sp>
+      <p:sp>
+        <p:nvSpPr>
+          <p:cNvPr id="6" name="Shape 4"/>
+          <p:cNvSpPr/>
+          <p:nvPr/>
+        </p:nvSpPr>
+        <p:spPr>
+          <a:xfrm flipV="1">
+            <a:off x="6537960" y="992124"/>
+            <a:ext cx="340157" cy="-311810"/>
+          </a:xfrm>
+          <a:prstGeom prst="line">
+            <a:avLst/>
+          </a:prstGeom>
+          <a:noFill/>
+          <a:ln w="13970">
+            <a:solidFill>
+              <a:srgbClr val="B8985A"/>
+            </a:solidFill>
+            <a:prstDash val="solid"/>
+          </a:ln>
+        </p:spPr>
+      </p:sp>
+      <p:sp>
+        <p:nvSpPr>
+          <p:cNvPr id="7" name="Shape 5"/>
+          <p:cNvSpPr/>
+          <p:nvPr/>
+        </p:nvSpPr>
+        <p:spPr>
+          <a:xfrm flipV="1">
+            <a:off x="6537960" y="1247242"/>
+            <a:ext cx="238110" cy="-255118"/>
+          </a:xfrm>
+          <a:prstGeom prst="line">
+            <a:avLst/>
+          </a:prstGeom>
+          <a:noFill/>
+          <a:ln w="11430">
+            <a:solidFill>
+              <a:srgbClr val="B8985A"/>
+            </a:solidFill>
+            <a:prstDash val="solid"/>
+          </a:ln>
+        </p:spPr>
+      </p:sp>
+      <p:sp>
+        <p:nvSpPr>
+          <p:cNvPr id="8" name="Shape 6"/>
+          <p:cNvSpPr/>
+          <p:nvPr/>
+        </p:nvSpPr>
+        <p:spPr>
+          <a:xfrm flipV="1">
+            <a:off x="6537960" y="1179210"/>
+            <a:ext cx="-192756" cy="-170078"/>
+          </a:xfrm>
+          <a:prstGeom prst="line">
+            <a:avLst/>
+          </a:prstGeom>
+          <a:noFill/>
+          <a:ln w="11430">
+            <a:solidFill>
+              <a:srgbClr val="B8985A"/>
+            </a:solidFill>
+            <a:prstDash val="solid"/>
+          </a:ln>
+        </p:spPr>
+      </p:sp>
+      <p:sp>
+        <p:nvSpPr>
+          <p:cNvPr id="9" name="Shape 7"/>
+          <p:cNvSpPr/>
+          <p:nvPr/>
+        </p:nvSpPr>
+        <p:spPr>
+          <a:xfrm>
+            <a:off x="6537960" y="1729130"/>
+            <a:ext cx="-351495" cy="283464"/>
+          </a:xfrm>
+          <a:prstGeom prst="line">
+            <a:avLst/>
+          </a:prstGeom>
+          <a:noFill/>
+          <a:ln w="13970">
+            <a:solidFill>
+              <a:srgbClr val="B8985A"/>
+            </a:solidFill>
+            <a:prstDash val="solid"/>
+          </a:ln>
+        </p:spPr>
+      </p:sp>
+      <p:sp>
+        <p:nvSpPr>
+          <p:cNvPr id="10" name="Shape 8"/>
+          <p:cNvSpPr/>
+          <p:nvPr/>
+        </p:nvSpPr>
+        <p:spPr>
+          <a:xfrm>
+            <a:off x="6537960" y="1814170"/>
+            <a:ext cx="328818" cy="255118"/>
+          </a:xfrm>
+          <a:prstGeom prst="line">
+            <a:avLst/>
+          </a:prstGeom>
+          <a:noFill/>
+          <a:ln w="13970">
+            <a:solidFill>
+              <a:srgbClr val="B8985A"/>
+            </a:solidFill>
+            <a:prstDash val="solid"/>
+          </a:ln>
+        </p:spPr>
+      </p:sp>
+      <p:sp>
+        <p:nvSpPr>
+          <p:cNvPr id="11" name="Shape 9"/>
+          <p:cNvSpPr/>
+          <p:nvPr/>
+        </p:nvSpPr>
+        <p:spPr>
+          <a:xfrm>
+            <a:off x="6537960" y="1615745"/>
+            <a:ext cx="170078" cy="198425"/>
+          </a:xfrm>
+          <a:prstGeom prst="line">
+            <a:avLst/>
+          </a:prstGeom>
+          <a:noFill/>
+          <a:ln w="11430">
+            <a:solidFill>
+              <a:srgbClr val="B8985A"/>
+            </a:solidFill>
+            <a:prstDash val="solid"/>
+          </a:ln>
+        </p:spPr>
+      </p:sp>
+      <p:sp>
+        <p:nvSpPr>
+          <p:cNvPr id="12" name="Shape 10"/>
+          <p:cNvSpPr/>
+          <p:nvPr/>
+        </p:nvSpPr>
+        <p:spPr>
+          <a:xfrm>
+            <a:off x="6537960" y="1672438"/>
+            <a:ext cx="-158740" cy="187086"/>
+          </a:xfrm>
+          <a:prstGeom prst="line">
+            <a:avLst/>
+          </a:prstGeom>
+          <a:noFill/>
+          <a:ln w="11430">
+            <a:solidFill>
+              <a:srgbClr val="B8985A"/>
+            </a:solidFill>
+            <a:prstDash val="solid"/>
+          </a:ln>
+        </p:spPr>
+      </p:sp>
+      <p:sp>
+        <p:nvSpPr>
+          <p:cNvPr id="13" name="Shape 11"/>
+          <p:cNvSpPr/>
+          <p:nvPr/>
+        </p:nvSpPr>
+        <p:spPr>
+          <a:xfrm>
+            <a:off x="6056071" y="1928470"/>
+            <a:ext cx="963778" cy="0"/>
+          </a:xfrm>
+          <a:prstGeom prst="line">
+            <a:avLst/>
+          </a:prstGeom>
+          <a:noFill/>
+          <a:ln w="9525">
+            <a:solidFill>
+              <a:srgbClr val="D9D2C4"/>
+            </a:solidFill>
+            <a:prstDash val="solid"/>
+          </a:ln>
+        </p:spPr>
+      </p:sp>
+      <p:sp>
+        <p:nvSpPr>
+          <p:cNvPr id="14" name="Text 12"/>
+          <p:cNvSpPr/>
+          <p:nvPr/>
+        </p:nvSpPr>
+        <p:spPr>
+          <a:xfrm>
+            <a:off x="777240" y="1600200"/>
+            <a:ext cx="5212080" cy="1280160"/>
           </a:xfrm>
           <a:prstGeom prst="rect">
             <a:avLst/>
@@ -919,33 +1205,101 @@
           <a:lstStyle/>
           <a:p>
             <a:pPr indent="0" marL="0">
-              <a:buNone/>
-            </a:pPr>
-            <a:r>
-              <a:rPr lang="en-US" sz="1500" b="1" spc="400" kern="0" dirty="0">
-                <a:solidFill>
-                  <a:srgbClr val="C2A35B"/>
+              <a:lnSpc>
+                <a:spcPts val="3600"/>
+              </a:lnSpc>
+              <a:buNone/>
+            </a:pPr>
+            <a:r>
+              <a:rPr lang="en-US" sz="3000" b="1" dirty="0">
+                <a:solidFill>
+                  <a:srgbClr val="1B2A4A"/>
+                </a:solidFill>
+                <a:latin typeface="Cambria" pitchFamily="34" charset="0"/>
+                <a:ea typeface="Cambria" pitchFamily="34" charset="-122"/>
+                <a:cs typeface="Cambria" pitchFamily="34" charset="-120"/>
+              </a:rPr>
+              <a:t>Tornamos a sua empresa AI native.</a:t>
+            </a:r>
+            <a:endParaRPr lang="en-US" sz="3000" dirty="0"/>
+          </a:p>
+        </p:txBody>
+      </p:sp>
+      <p:sp>
+        <p:nvSpPr>
+          <p:cNvPr id="15" name="Text 13"/>
+          <p:cNvSpPr/>
+          <p:nvPr/>
+        </p:nvSpPr>
+        <p:spPr>
+          <a:xfrm>
+            <a:off x="777240" y="2971800"/>
+            <a:ext cx="6007608" cy="640080"/>
+          </a:xfrm>
+          <a:prstGeom prst="rect">
+            <a:avLst/>
+          </a:prstGeom>
+          <a:noFill/>
+          <a:ln/>
+        </p:spPr>
+        <p:txBody>
+          <a:bodyPr wrap="square" lIns="0" tIns="0" rIns="0" bIns="0" rtlCol="0" anchor="ctr"/>
+          <a:lstStyle/>
+          <a:p>
+            <a:pPr indent="0" marL="0">
+              <a:lnSpc>
+                <a:spcPts val="1550"/>
+              </a:lnSpc>
+              <a:buNone/>
+            </a:pPr>
+            <a:r>
+              <a:rPr lang="en-US" sz="1100" dirty="0">
+                <a:solidFill>
+                  <a:srgbClr val="232B3A"/>
                 </a:solidFill>
                 <a:latin typeface="Calibri" pitchFamily="34" charset="0"/>
                 <a:ea typeface="Calibri" pitchFamily="34" charset="-122"/>
                 <a:cs typeface="Calibri" pitchFamily="34" charset="-120"/>
               </a:rPr>
-              <a:t>ABBA</a:t>
-            </a:r>
-            <a:endParaRPr lang="en-US" sz="1500" dirty="0"/>
-          </a:p>
-        </p:txBody>
-      </p:sp>
-      <p:sp>
-        <p:nvSpPr>
-          <p:cNvPr id="4" name="Text 2"/>
-          <p:cNvSpPr/>
-          <p:nvPr/>
-        </p:nvSpPr>
-        <p:spPr>
-          <a:xfrm>
-            <a:off x="548640" y="768096"/>
-            <a:ext cx="4572000" cy="274320"/>
+              <a:t>Construímos as soluções que melhoram o dia a dia da operação, formamos as pessoas para trabalhar com IA — e provamos o que mudou, com número combinado antes e medido depois.</a:t>
+            </a:r>
+            <a:endParaRPr lang="en-US" sz="1100" dirty="0"/>
+          </a:p>
+        </p:txBody>
+      </p:sp>
+      <p:sp>
+        <p:nvSpPr>
+          <p:cNvPr id="16" name="Shape 14"/>
+          <p:cNvSpPr/>
+          <p:nvPr/>
+        </p:nvSpPr>
+        <p:spPr>
+          <a:xfrm>
+            <a:off x="777240" y="3840480"/>
+            <a:ext cx="6007608" cy="0"/>
+          </a:xfrm>
+          <a:prstGeom prst="line">
+            <a:avLst/>
+          </a:prstGeom>
+          <a:noFill/>
+          <a:ln w="9525">
+            <a:solidFill>
+              <a:srgbClr val="D9D2C4"/>
+            </a:solidFill>
+            <a:prstDash val="solid"/>
+          </a:ln>
+        </p:spPr>
+      </p:sp>
+      <p:sp>
+        <p:nvSpPr>
+          <p:cNvPr id="17" name="Text 15"/>
+          <p:cNvSpPr/>
+          <p:nvPr/>
+        </p:nvSpPr>
+        <p:spPr>
+          <a:xfrm>
+            <a:off x="777240" y="4005072"/>
+            <a:ext cx="6007608" cy="219456"/>
           </a:xfrm>
           <a:prstGeom prst="rect">
             <a:avLst/>
@@ -961,30 +1315,30 @@
               <a:buNone/>
             </a:pPr>
             <a:r>
-              <a:rPr lang="en-US" sz="1050" dirty="0">
-                <a:solidFill>
-                  <a:srgbClr val="C9D2E4"/>
+              <a:rPr lang="en-US" sz="900" b="1" spc="320" kern="0" dirty="0">
+                <a:solidFill>
+                  <a:srgbClr val="B8985A"/>
                 </a:solidFill>
                 <a:latin typeface="Calibri" pitchFamily="34" charset="0"/>
                 <a:ea typeface="Calibri" pitchFamily="34" charset="-122"/>
                 <a:cs typeface="Calibri" pitchFamily="34" charset="-120"/>
               </a:rPr>
-              <a:t>Consultoria de Inteligência Artificial</a:t>
-            </a:r>
-            <a:endParaRPr lang="en-US" sz="1050" dirty="0"/>
-          </a:p>
-        </p:txBody>
-      </p:sp>
-      <p:sp>
-        <p:nvSpPr>
-          <p:cNvPr id="5" name="Text 3"/>
-          <p:cNvSpPr/>
-          <p:nvPr/>
-        </p:nvSpPr>
-        <p:spPr>
-          <a:xfrm>
-            <a:off x="548640" y="1463040"/>
-            <a:ext cx="6492240" cy="1188720"/>
+              <a:t>A JORNADA, EM SETE PASSOS</a:t>
+            </a:r>
+            <a:endParaRPr lang="en-US" sz="900" dirty="0"/>
+          </a:p>
+        </p:txBody>
+      </p:sp>
+      <p:sp>
+        <p:nvSpPr>
+          <p:cNvPr id="18" name="Text 16"/>
+          <p:cNvSpPr/>
+          <p:nvPr/>
+        </p:nvSpPr>
+        <p:spPr>
+          <a:xfrm>
+            <a:off x="777240" y="4288536"/>
+            <a:ext cx="457200" cy="457200"/>
           </a:xfrm>
           <a:prstGeom prst="rect">
             <a:avLst/>
@@ -1000,47 +1354,233 @@
               <a:buNone/>
             </a:pPr>
             <a:r>
-              <a:rPr lang="en-US" sz="3000" b="1" dirty="0">
-                <a:solidFill>
-                  <a:srgbClr val="FFFFFF"/>
+              <a:rPr lang="en-US" sz="2100" b="1" dirty="0">
+                <a:solidFill>
+                  <a:srgbClr val="B8985A"/>
+                </a:solidFill>
+                <a:latin typeface="Cambria" pitchFamily="34" charset="0"/>
+                <a:ea typeface="Cambria" pitchFamily="34" charset="-122"/>
+                <a:cs typeface="Cambria" pitchFamily="34" charset="-120"/>
+              </a:rPr>
+              <a:t>1</a:t>
+            </a:r>
+            <a:endParaRPr lang="en-US" sz="2100" dirty="0"/>
+          </a:p>
+        </p:txBody>
+      </p:sp>
+      <p:sp>
+        <p:nvSpPr>
+          <p:cNvPr id="19" name="Text 17"/>
+          <p:cNvSpPr/>
+          <p:nvPr/>
+        </p:nvSpPr>
+        <p:spPr>
+          <a:xfrm>
+            <a:off x="1325880" y="4343400"/>
+            <a:ext cx="5458968" cy="475488"/>
+          </a:xfrm>
+          <a:prstGeom prst="rect">
+            <a:avLst/>
+          </a:prstGeom>
+          <a:noFill/>
+          <a:ln/>
+        </p:spPr>
+        <p:txBody>
+          <a:bodyPr wrap="square" lIns="0" tIns="0" rIns="0" bIns="0" rtlCol="0" anchor="ctr"/>
+          <a:lstStyle/>
+          <a:p>
+            <a:pPr indent="0" marL="0">
+              <a:lnSpc>
+                <a:spcPts val="1350"/>
+              </a:lnSpc>
+              <a:buNone/>
+            </a:pPr>
+            <a:r>
+              <a:rPr lang="en-US" sz="1150" b="1" dirty="0">
+                <a:solidFill>
+                  <a:srgbClr val="1B2A4A"/>
+                </a:solidFill>
+                <a:latin typeface="Cambria" pitchFamily="34" charset="0"/>
+                <a:ea typeface="Cambria" pitchFamily="34" charset="-122"/>
+                <a:cs typeface="Cambria" pitchFamily="34" charset="-120"/>
+              </a:rPr>
+              <a:t>A primeira conversa  —  </a:t>
+            </a:r>
+            <a:pPr indent="0" marL="0">
+              <a:lnSpc>
+                <a:spcPts val="1350"/>
+              </a:lnSpc>
+              <a:buNone/>
+            </a:pPr>
+            <a:r>
+              <a:rPr lang="en-US" sz="980" dirty="0">
+                <a:solidFill>
+                  <a:srgbClr val="232B3A"/>
                 </a:solidFill>
                 <a:latin typeface="Calibri" pitchFamily="34" charset="0"/>
                 <a:ea typeface="Calibri" pitchFamily="34" charset="-122"/>
                 <a:cs typeface="Calibri" pitchFamily="34" charset="-120"/>
               </a:rPr>
-              <a:t>Tornamos a sua empresa</a:t>
-            </a:r>
-            <a:endParaRPr lang="en-US" sz="3000" dirty="0"/>
-          </a:p>
-          <a:p>
-            <a:pPr indent="0" marL="0">
-              <a:buNone/>
-            </a:pPr>
-            <a:r>
-              <a:rPr lang="en-US" sz="3000" b="1" dirty="0">
-                <a:solidFill>
-                  <a:srgbClr val="FFFFFF"/>
+              <a:t>45 minutos — e o Mapa de Vazamento gratuito, com uma estimativa em reais do que pode estar vazando.</a:t>
+            </a:r>
+            <a:endParaRPr lang="en-US" sz="1150" dirty="0"/>
+          </a:p>
+        </p:txBody>
+      </p:sp>
+      <p:sp>
+        <p:nvSpPr>
+          <p:cNvPr id="20" name="Shape 18"/>
+          <p:cNvSpPr/>
+          <p:nvPr/>
+        </p:nvSpPr>
+        <p:spPr>
+          <a:xfrm>
+            <a:off x="1325880" y="4837176"/>
+            <a:ext cx="5458968" cy="0"/>
+          </a:xfrm>
+          <a:prstGeom prst="line">
+            <a:avLst/>
+          </a:prstGeom>
+          <a:noFill/>
+          <a:ln w="9525">
+            <a:solidFill>
+              <a:srgbClr val="D9D2C4"/>
+            </a:solidFill>
+            <a:prstDash val="solid"/>
+          </a:ln>
+        </p:spPr>
+      </p:sp>
+      <p:sp>
+        <p:nvSpPr>
+          <p:cNvPr id="21" name="Text 19"/>
+          <p:cNvSpPr/>
+          <p:nvPr/>
+        </p:nvSpPr>
+        <p:spPr>
+          <a:xfrm>
+            <a:off x="777240" y="4855464"/>
+            <a:ext cx="457200" cy="457200"/>
+          </a:xfrm>
+          <a:prstGeom prst="rect">
+            <a:avLst/>
+          </a:prstGeom>
+          <a:noFill/>
+          <a:ln/>
+        </p:spPr>
+        <p:txBody>
+          <a:bodyPr wrap="square" lIns="0" tIns="0" rIns="0" bIns="0" rtlCol="0" anchor="ctr"/>
+          <a:lstStyle/>
+          <a:p>
+            <a:pPr indent="0" marL="0">
+              <a:buNone/>
+            </a:pPr>
+            <a:r>
+              <a:rPr lang="en-US" sz="2100" b="1" dirty="0">
+                <a:solidFill>
+                  <a:srgbClr val="B8985A"/>
+                </a:solidFill>
+                <a:latin typeface="Cambria" pitchFamily="34" charset="0"/>
+                <a:ea typeface="Cambria" pitchFamily="34" charset="-122"/>
+                <a:cs typeface="Cambria" pitchFamily="34" charset="-120"/>
+              </a:rPr>
+              <a:t>2</a:t>
+            </a:r>
+            <a:endParaRPr lang="en-US" sz="2100" dirty="0"/>
+          </a:p>
+        </p:txBody>
+      </p:sp>
+      <p:sp>
+        <p:nvSpPr>
+          <p:cNvPr id="22" name="Text 20"/>
+          <p:cNvSpPr/>
+          <p:nvPr/>
+        </p:nvSpPr>
+        <p:spPr>
+          <a:xfrm>
+            <a:off x="1325880" y="4910328"/>
+            <a:ext cx="5458968" cy="475488"/>
+          </a:xfrm>
+          <a:prstGeom prst="rect">
+            <a:avLst/>
+          </a:prstGeom>
+          <a:noFill/>
+          <a:ln/>
+        </p:spPr>
+        <p:txBody>
+          <a:bodyPr wrap="square" lIns="0" tIns="0" rIns="0" bIns="0" rtlCol="0" anchor="ctr"/>
+          <a:lstStyle/>
+          <a:p>
+            <a:pPr indent="0" marL="0">
+              <a:lnSpc>
+                <a:spcPts val="1350"/>
+              </a:lnSpc>
+              <a:buNone/>
+            </a:pPr>
+            <a:r>
+              <a:rPr lang="en-US" sz="1150" b="1" dirty="0">
+                <a:solidFill>
+                  <a:srgbClr val="1B2A4A"/>
+                </a:solidFill>
+                <a:latin typeface="Cambria" pitchFamily="34" charset="0"/>
+                <a:ea typeface="Cambria" pitchFamily="34" charset="-122"/>
+                <a:cs typeface="Cambria" pitchFamily="34" charset="-120"/>
+              </a:rPr>
+              <a:t>Assessment  —  </a:t>
+            </a:r>
+            <a:pPr indent="0" marL="0">
+              <a:lnSpc>
+                <a:spcPts val="1350"/>
+              </a:lnSpc>
+              <a:buNone/>
+            </a:pPr>
+            <a:r>
+              <a:rPr lang="en-US" sz="980" dirty="0">
+                <a:solidFill>
+                  <a:srgbClr val="232B3A"/>
                 </a:solidFill>
                 <a:latin typeface="Calibri" pitchFamily="34" charset="0"/>
                 <a:ea typeface="Calibri" pitchFamily="34" charset="-122"/>
                 <a:cs typeface="Calibri" pitchFamily="34" charset="-120"/>
               </a:rPr>
-              <a:t>AI native.</a:t>
-            </a:r>
-            <a:endParaRPr lang="en-US" sz="3000" dirty="0"/>
-          </a:p>
-        </p:txBody>
-      </p:sp>
-      <p:sp>
-        <p:nvSpPr>
-          <p:cNvPr id="6" name="Text 4"/>
-          <p:cNvSpPr/>
-          <p:nvPr/>
-        </p:nvSpPr>
-        <p:spPr>
-          <a:xfrm>
-            <a:off x="548640" y="2743200"/>
-            <a:ext cx="6492240" cy="685800"/>
+              <a:t>O mergulho em 25 dimensões, do conselho à linha de frente. Sai um portfólio ranqueado e quantificado.</a:t>
+            </a:r>
+            <a:endParaRPr lang="en-US" sz="1150" dirty="0"/>
+          </a:p>
+        </p:txBody>
+      </p:sp>
+      <p:sp>
+        <p:nvSpPr>
+          <p:cNvPr id="23" name="Shape 21"/>
+          <p:cNvSpPr/>
+          <p:nvPr/>
+        </p:nvSpPr>
+        <p:spPr>
+          <a:xfrm>
+            <a:off x="1325880" y="5404104"/>
+            <a:ext cx="5458968" cy="0"/>
+          </a:xfrm>
+          <a:prstGeom prst="line">
+            <a:avLst/>
+          </a:prstGeom>
+          <a:noFill/>
+          <a:ln w="9525">
+            <a:solidFill>
+              <a:srgbClr val="D9D2C4"/>
+            </a:solidFill>
+            <a:prstDash val="solid"/>
+          </a:ln>
+        </p:spPr>
+      </p:sp>
+      <p:sp>
+        <p:nvSpPr>
+          <p:cNvPr id="24" name="Text 22"/>
+          <p:cNvSpPr/>
+          <p:nvPr/>
+        </p:nvSpPr>
+        <p:spPr>
+          <a:xfrm>
+            <a:off x="777240" y="5422392"/>
+            <a:ext cx="457200" cy="457200"/>
           </a:xfrm>
           <a:prstGeom prst="rect">
             <a:avLst/>
@@ -1056,30 +1596,112 @@
               <a:buNone/>
             </a:pPr>
             <a:r>
-              <a:rPr lang="en-US" sz="1200" dirty="0">
-                <a:solidFill>
-                  <a:srgbClr val="C9D2E4"/>
+              <a:rPr lang="en-US" sz="2100" b="1" dirty="0">
+                <a:solidFill>
+                  <a:srgbClr val="B8985A"/>
+                </a:solidFill>
+                <a:latin typeface="Cambria" pitchFamily="34" charset="0"/>
+                <a:ea typeface="Cambria" pitchFamily="34" charset="-122"/>
+                <a:cs typeface="Cambria" pitchFamily="34" charset="-120"/>
+              </a:rPr>
+              <a:t>3</a:t>
+            </a:r>
+            <a:endParaRPr lang="en-US" sz="2100" dirty="0"/>
+          </a:p>
+        </p:txBody>
+      </p:sp>
+      <p:sp>
+        <p:nvSpPr>
+          <p:cNvPr id="25" name="Text 23"/>
+          <p:cNvSpPr/>
+          <p:nvPr/>
+        </p:nvSpPr>
+        <p:spPr>
+          <a:xfrm>
+            <a:off x="1325880" y="5477256"/>
+            <a:ext cx="5458968" cy="475488"/>
+          </a:xfrm>
+          <a:prstGeom prst="rect">
+            <a:avLst/>
+          </a:prstGeom>
+          <a:noFill/>
+          <a:ln/>
+        </p:spPr>
+        <p:txBody>
+          <a:bodyPr wrap="square" lIns="0" tIns="0" rIns="0" bIns="0" rtlCol="0" anchor="ctr"/>
+          <a:lstStyle/>
+          <a:p>
+            <a:pPr indent="0" marL="0">
+              <a:lnSpc>
+                <a:spcPts val="1350"/>
+              </a:lnSpc>
+              <a:buNone/>
+            </a:pPr>
+            <a:r>
+              <a:rPr lang="en-US" sz="1150" b="1" dirty="0">
+                <a:solidFill>
+                  <a:srgbClr val="1B2A4A"/>
+                </a:solidFill>
+                <a:latin typeface="Cambria" pitchFamily="34" charset="0"/>
+                <a:ea typeface="Cambria" pitchFamily="34" charset="-122"/>
+                <a:cs typeface="Cambria" pitchFamily="34" charset="-120"/>
+              </a:rPr>
+              <a:t>Protótipo de caso de uso  —  </a:t>
+            </a:r>
+            <a:pPr indent="0" marL="0">
+              <a:lnSpc>
+                <a:spcPts val="1350"/>
+              </a:lnSpc>
+              <a:buNone/>
+            </a:pPr>
+            <a:r>
+              <a:rPr lang="en-US" sz="980" dirty="0">
+                <a:solidFill>
+                  <a:srgbClr val="232B3A"/>
                 </a:solidFill>
                 <a:latin typeface="Calibri" pitchFamily="34" charset="0"/>
                 <a:ea typeface="Calibri" pitchFamily="34" charset="-122"/>
                 <a:cs typeface="Calibri" pitchFamily="34" charset="-120"/>
               </a:rPr>
-              <a:t>Construímos as soluções que melhoram o dia a dia da operação, formamos as pessoas para trabalhar com IA — e provamos o que mudou, com número combinado antes e medido depois.</a:t>
-            </a:r>
-            <a:endParaRPr lang="en-US" sz="1200" dirty="0"/>
-          </a:p>
-        </p:txBody>
-      </p:sp>
-      <p:sp>
-        <p:nvSpPr>
-          <p:cNvPr id="7" name="Text 5"/>
-          <p:cNvSpPr/>
-          <p:nvPr/>
-        </p:nvSpPr>
-        <p:spPr>
-          <a:xfrm>
-            <a:off x="548640" y="3703320"/>
-            <a:ext cx="6400800" cy="274320"/>
+              <a:t>Validação com os seus dados reais. A diretoria decide GO ou NO-GO com números na mesa.</a:t>
+            </a:r>
+            <a:endParaRPr lang="en-US" sz="1150" dirty="0"/>
+          </a:p>
+        </p:txBody>
+      </p:sp>
+      <p:sp>
+        <p:nvSpPr>
+          <p:cNvPr id="26" name="Shape 24"/>
+          <p:cNvSpPr/>
+          <p:nvPr/>
+        </p:nvSpPr>
+        <p:spPr>
+          <a:xfrm>
+            <a:off x="1325880" y="5971032"/>
+            <a:ext cx="5458968" cy="0"/>
+          </a:xfrm>
+          <a:prstGeom prst="line">
+            <a:avLst/>
+          </a:prstGeom>
+          <a:noFill/>
+          <a:ln w="9525">
+            <a:solidFill>
+              <a:srgbClr val="D9D2C4"/>
+            </a:solidFill>
+            <a:prstDash val="solid"/>
+          </a:ln>
+        </p:spPr>
+      </p:sp>
+      <p:sp>
+        <p:nvSpPr>
+          <p:cNvPr id="27" name="Text 25"/>
+          <p:cNvSpPr/>
+          <p:nvPr/>
+        </p:nvSpPr>
+        <p:spPr>
+          <a:xfrm>
+            <a:off x="777240" y="5989320"/>
+            <a:ext cx="457200" cy="457200"/>
           </a:xfrm>
           <a:prstGeom prst="rect">
             <a:avLst/>
@@ -1095,42 +1717,97 @@
               <a:buNone/>
             </a:pPr>
             <a:r>
-              <a:rPr lang="en-US" sz="1300" b="1" dirty="0">
-                <a:solidFill>
-                  <a:srgbClr val="C2A35B"/>
+              <a:rPr lang="en-US" sz="2100" b="1" dirty="0">
+                <a:solidFill>
+                  <a:srgbClr val="B8985A"/>
+                </a:solidFill>
+                <a:latin typeface="Cambria" pitchFamily="34" charset="0"/>
+                <a:ea typeface="Cambria" pitchFamily="34" charset="-122"/>
+                <a:cs typeface="Cambria" pitchFamily="34" charset="-120"/>
+              </a:rPr>
+              <a:t>4</a:t>
+            </a:r>
+            <a:endParaRPr lang="en-US" sz="2100" dirty="0"/>
+          </a:p>
+        </p:txBody>
+      </p:sp>
+      <p:sp>
+        <p:nvSpPr>
+          <p:cNvPr id="28" name="Text 26"/>
+          <p:cNvSpPr/>
+          <p:nvPr/>
+        </p:nvSpPr>
+        <p:spPr>
+          <a:xfrm>
+            <a:off x="1325880" y="6044184"/>
+            <a:ext cx="5458968" cy="475488"/>
+          </a:xfrm>
+          <a:prstGeom prst="rect">
+            <a:avLst/>
+          </a:prstGeom>
+          <a:noFill/>
+          <a:ln/>
+        </p:spPr>
+        <p:txBody>
+          <a:bodyPr wrap="square" lIns="0" tIns="0" rIns="0" bIns="0" rtlCol="0" anchor="ctr"/>
+          <a:lstStyle/>
+          <a:p>
+            <a:pPr indent="0" marL="0">
+              <a:lnSpc>
+                <a:spcPts val="1350"/>
+              </a:lnSpc>
+              <a:buNone/>
+            </a:pPr>
+            <a:r>
+              <a:rPr lang="en-US" sz="1150" b="1" dirty="0">
+                <a:solidFill>
+                  <a:srgbClr val="1B2A4A"/>
+                </a:solidFill>
+                <a:latin typeface="Cambria" pitchFamily="34" charset="0"/>
+                <a:ea typeface="Cambria" pitchFamily="34" charset="-122"/>
+                <a:cs typeface="Cambria" pitchFamily="34" charset="-120"/>
+              </a:rPr>
+              <a:t>Construção e implantação  —  </a:t>
+            </a:r>
+            <a:pPr indent="0" marL="0">
+              <a:lnSpc>
+                <a:spcPts val="1350"/>
+              </a:lnSpc>
+              <a:buNone/>
+            </a:pPr>
+            <a:r>
+              <a:rPr lang="en-US" sz="980" dirty="0">
+                <a:solidFill>
+                  <a:srgbClr val="232B3A"/>
                 </a:solidFill>
                 <a:latin typeface="Calibri" pitchFamily="34" charset="0"/>
                 <a:ea typeface="Calibri" pitchFamily="34" charset="-122"/>
                 <a:cs typeface="Calibri" pitchFamily="34" charset="-120"/>
               </a:rPr>
-              <a:t>Os serviços</a:t>
-            </a:r>
-            <a:endParaRPr lang="en-US" sz="1300" dirty="0"/>
-          </a:p>
-        </p:txBody>
-      </p:sp>
-      <p:sp>
-        <p:nvSpPr>
-          <p:cNvPr id="8" name="Shape 6"/>
-          <p:cNvSpPr/>
-          <p:nvPr/>
-        </p:nvSpPr>
-        <p:spPr>
-          <a:xfrm>
-            <a:off x="548640" y="4069080"/>
-            <a:ext cx="6492240" cy="475488"/>
-          </a:xfrm>
-          <a:prstGeom prst="roundRect">
-            <a:avLst>
-              <a:gd name="adj" fmla="val 19231"/>
-            </a:avLst>
-          </a:prstGeom>
-          <a:solidFill>
-            <a:srgbClr val="24365E"/>
-          </a:solidFill>
-          <a:ln w="6350">
+              <a:t>Agentes sob medida, em produção, com aprovação humana em tudo que é crítico.</a:t>
+            </a:r>
+            <a:endParaRPr lang="en-US" sz="1150" dirty="0"/>
+          </a:p>
+        </p:txBody>
+      </p:sp>
+      <p:sp>
+        <p:nvSpPr>
+          <p:cNvPr id="29" name="Shape 27"/>
+          <p:cNvSpPr/>
+          <p:nvPr/>
+        </p:nvSpPr>
+        <p:spPr>
+          <a:xfrm>
+            <a:off x="1325880" y="6537960"/>
+            <a:ext cx="5458968" cy="0"/>
+          </a:xfrm>
+          <a:prstGeom prst="line">
+            <a:avLst/>
+          </a:prstGeom>
+          <a:noFill/>
+          <a:ln w="9525">
             <a:solidFill>
-              <a:srgbClr val="C2A35B"/>
+              <a:srgbClr val="D9D2C4"/>
             </a:solidFill>
             <a:prstDash val="solid"/>
           </a:ln>
@@ -1138,14 +1815,14 @@
       </p:sp>
       <p:sp>
         <p:nvSpPr>
-          <p:cNvPr id="9" name="Text 7"/>
-          <p:cNvSpPr/>
-          <p:nvPr/>
-        </p:nvSpPr>
-        <p:spPr>
-          <a:xfrm>
-            <a:off x="777240" y="4142232"/>
-            <a:ext cx="6126480" cy="347472"/>
+          <p:cNvPr id="30" name="Text 28"/>
+          <p:cNvSpPr/>
+          <p:nvPr/>
+        </p:nvSpPr>
+        <p:spPr>
+          <a:xfrm>
+            <a:off x="777240" y="6556248"/>
+            <a:ext cx="457200" cy="457200"/>
           </a:xfrm>
           <a:prstGeom prst="rect">
             <a:avLst/>
@@ -1161,42 +1838,97 @@
               <a:buNone/>
             </a:pPr>
             <a:r>
-              <a:rPr lang="en-US" sz="1050" dirty="0">
-                <a:solidFill>
-                  <a:srgbClr val="FFFFFF"/>
+              <a:rPr lang="en-US" sz="2100" b="1" dirty="0">
+                <a:solidFill>
+                  <a:srgbClr val="B8985A"/>
+                </a:solidFill>
+                <a:latin typeface="Cambria" pitchFamily="34" charset="0"/>
+                <a:ea typeface="Cambria" pitchFamily="34" charset="-122"/>
+                <a:cs typeface="Cambria" pitchFamily="34" charset="-120"/>
+              </a:rPr>
+              <a:t>5</a:t>
+            </a:r>
+            <a:endParaRPr lang="en-US" sz="2100" dirty="0"/>
+          </a:p>
+        </p:txBody>
+      </p:sp>
+      <p:sp>
+        <p:nvSpPr>
+          <p:cNvPr id="31" name="Text 29"/>
+          <p:cNvSpPr/>
+          <p:nvPr/>
+        </p:nvSpPr>
+        <p:spPr>
+          <a:xfrm>
+            <a:off x="1325880" y="6611112"/>
+            <a:ext cx="5458968" cy="475488"/>
+          </a:xfrm>
+          <a:prstGeom prst="rect">
+            <a:avLst/>
+          </a:prstGeom>
+          <a:noFill/>
+          <a:ln/>
+        </p:spPr>
+        <p:txBody>
+          <a:bodyPr wrap="square" lIns="0" tIns="0" rIns="0" bIns="0" rtlCol="0" anchor="ctr"/>
+          <a:lstStyle/>
+          <a:p>
+            <a:pPr indent="0" marL="0">
+              <a:lnSpc>
+                <a:spcPts val="1350"/>
+              </a:lnSpc>
+              <a:buNone/>
+            </a:pPr>
+            <a:r>
+              <a:rPr lang="en-US" sz="1150" b="1" dirty="0">
+                <a:solidFill>
+                  <a:srgbClr val="1B2A4A"/>
+                </a:solidFill>
+                <a:latin typeface="Cambria" pitchFamily="34" charset="0"/>
+                <a:ea typeface="Cambria" pitchFamily="34" charset="-122"/>
+                <a:cs typeface="Cambria" pitchFamily="34" charset="-120"/>
+              </a:rPr>
+              <a:t>Treinamento + ABBA Portal  —  </a:t>
+            </a:r>
+            <a:pPr indent="0" marL="0">
+              <a:lnSpc>
+                <a:spcPts val="1350"/>
+              </a:lnSpc>
+              <a:buNone/>
+            </a:pPr>
+            <a:r>
+              <a:rPr lang="en-US" sz="980" dirty="0">
+                <a:solidFill>
+                  <a:srgbClr val="232B3A"/>
                 </a:solidFill>
                 <a:latin typeface="Calibri" pitchFamily="34" charset="0"/>
                 <a:ea typeface="Calibri" pitchFamily="34" charset="-122"/>
                 <a:cs typeface="Calibri" pitchFamily="34" charset="-120"/>
               </a:rPr>
-              <a:t>Assessment — mergulho em 25 dimensões, do conselho à linha de frente</a:t>
-            </a:r>
-            <a:endParaRPr lang="en-US" sz="1050" dirty="0"/>
-          </a:p>
-        </p:txBody>
-      </p:sp>
-      <p:sp>
-        <p:nvSpPr>
-          <p:cNvPr id="10" name="Shape 8"/>
-          <p:cNvSpPr/>
-          <p:nvPr/>
-        </p:nvSpPr>
-        <p:spPr>
-          <a:xfrm>
-            <a:off x="548640" y="4672584"/>
-            <a:ext cx="6492240" cy="475488"/>
-          </a:xfrm>
-          <a:prstGeom prst="roundRect">
-            <a:avLst>
-              <a:gd name="adj" fmla="val 19231"/>
-            </a:avLst>
-          </a:prstGeom>
-          <a:solidFill>
-            <a:srgbClr val="24365E"/>
-          </a:solidFill>
-          <a:ln w="6350">
+              <a:t>Todos os níveis: plataforma própria + presencial. Campeões internos carregam a transformação.</a:t>
+            </a:r>
+            <a:endParaRPr lang="en-US" sz="1150" dirty="0"/>
+          </a:p>
+        </p:txBody>
+      </p:sp>
+      <p:sp>
+        <p:nvSpPr>
+          <p:cNvPr id="32" name="Shape 30"/>
+          <p:cNvSpPr/>
+          <p:nvPr/>
+        </p:nvSpPr>
+        <p:spPr>
+          <a:xfrm>
+            <a:off x="1325880" y="7104888"/>
+            <a:ext cx="5458968" cy="0"/>
+          </a:xfrm>
+          <a:prstGeom prst="line">
+            <a:avLst/>
+          </a:prstGeom>
+          <a:noFill/>
+          <a:ln w="9525">
             <a:solidFill>
-              <a:srgbClr val="C2A35B"/>
+              <a:srgbClr val="D9D2C4"/>
             </a:solidFill>
             <a:prstDash val="solid"/>
           </a:ln>
@@ -1204,14 +1936,14 @@
       </p:sp>
       <p:sp>
         <p:nvSpPr>
-          <p:cNvPr id="11" name="Text 9"/>
-          <p:cNvSpPr/>
-          <p:nvPr/>
-        </p:nvSpPr>
-        <p:spPr>
-          <a:xfrm>
-            <a:off x="777240" y="4745736"/>
-            <a:ext cx="6126480" cy="347472"/>
+          <p:cNvPr id="33" name="Text 31"/>
+          <p:cNvSpPr/>
+          <p:nvPr/>
+        </p:nvSpPr>
+        <p:spPr>
+          <a:xfrm>
+            <a:off x="777240" y="7123176"/>
+            <a:ext cx="457200" cy="457200"/>
           </a:xfrm>
           <a:prstGeom prst="rect">
             <a:avLst/>
@@ -1227,42 +1959,97 @@
               <a:buNone/>
             </a:pPr>
             <a:r>
-              <a:rPr lang="en-US" sz="1050" dirty="0">
-                <a:solidFill>
-                  <a:srgbClr val="FFFFFF"/>
+              <a:rPr lang="en-US" sz="2100" b="1" dirty="0">
+                <a:solidFill>
+                  <a:srgbClr val="B8985A"/>
+                </a:solidFill>
+                <a:latin typeface="Cambria" pitchFamily="34" charset="0"/>
+                <a:ea typeface="Cambria" pitchFamily="34" charset="-122"/>
+                <a:cs typeface="Cambria" pitchFamily="34" charset="-120"/>
+              </a:rPr>
+              <a:t>6</a:t>
+            </a:r>
+            <a:endParaRPr lang="en-US" sz="2100" dirty="0"/>
+          </a:p>
+        </p:txBody>
+      </p:sp>
+      <p:sp>
+        <p:nvSpPr>
+          <p:cNvPr id="34" name="Text 32"/>
+          <p:cNvSpPr/>
+          <p:nvPr/>
+        </p:nvSpPr>
+        <p:spPr>
+          <a:xfrm>
+            <a:off x="1325880" y="7178040"/>
+            <a:ext cx="5458968" cy="475488"/>
+          </a:xfrm>
+          <a:prstGeom prst="rect">
+            <a:avLst/>
+          </a:prstGeom>
+          <a:noFill/>
+          <a:ln/>
+        </p:spPr>
+        <p:txBody>
+          <a:bodyPr wrap="square" lIns="0" tIns="0" rIns="0" bIns="0" rtlCol="0" anchor="ctr"/>
+          <a:lstStyle/>
+          <a:p>
+            <a:pPr indent="0" marL="0">
+              <a:lnSpc>
+                <a:spcPts val="1350"/>
+              </a:lnSpc>
+              <a:buNone/>
+            </a:pPr>
+            <a:r>
+              <a:rPr lang="en-US" sz="1150" b="1" dirty="0">
+                <a:solidFill>
+                  <a:srgbClr val="1B2A4A"/>
+                </a:solidFill>
+                <a:latin typeface="Cambria" pitchFamily="34" charset="0"/>
+                <a:ea typeface="Cambria" pitchFamily="34" charset="-122"/>
+                <a:cs typeface="Cambria" pitchFamily="34" charset="-120"/>
+              </a:rPr>
+              <a:t>Sistemas gerenciados  —  </a:t>
+            </a:r>
+            <a:pPr indent="0" marL="0">
+              <a:lnSpc>
+                <a:spcPts val="1350"/>
+              </a:lnSpc>
+              <a:buNone/>
+            </a:pPr>
+            <a:r>
+              <a:rPr lang="en-US" sz="980" dirty="0">
+                <a:solidFill>
+                  <a:srgbClr val="232B3A"/>
                 </a:solidFill>
                 <a:latin typeface="Calibri" pitchFamily="34" charset="0"/>
                 <a:ea typeface="Calibri" pitchFamily="34" charset="-122"/>
                 <a:cs typeface="Calibri" pitchFamily="34" charset="-120"/>
               </a:rPr>
-              <a:t>Protótipo de caso de uso — validação com dados reais, GO/NO-GO pela diretoria</a:t>
-            </a:r>
-            <a:endParaRPr lang="en-US" sz="1050" dirty="0"/>
-          </a:p>
-        </p:txBody>
-      </p:sp>
-      <p:sp>
-        <p:nvSpPr>
-          <p:cNvPr id="12" name="Shape 10"/>
-          <p:cNvSpPr/>
-          <p:nvPr/>
-        </p:nvSpPr>
-        <p:spPr>
-          <a:xfrm>
-            <a:off x="548640" y="5276088"/>
-            <a:ext cx="6492240" cy="475488"/>
-          </a:xfrm>
-          <a:prstGeom prst="roundRect">
-            <a:avLst>
-              <a:gd name="adj" fmla="val 19231"/>
-            </a:avLst>
-          </a:prstGeom>
-          <a:solidFill>
-            <a:srgbClr val="24365E"/>
-          </a:solidFill>
-          <a:ln w="6350">
+              <a:t>Operação com presença: ritual semanal de 20 minutos e o diário decisão → resultado medido.</a:t>
+            </a:r>
+            <a:endParaRPr lang="en-US" sz="1150" dirty="0"/>
+          </a:p>
+        </p:txBody>
+      </p:sp>
+      <p:sp>
+        <p:nvSpPr>
+          <p:cNvPr id="35" name="Shape 33"/>
+          <p:cNvSpPr/>
+          <p:nvPr/>
+        </p:nvSpPr>
+        <p:spPr>
+          <a:xfrm>
+            <a:off x="1325880" y="7671816"/>
+            <a:ext cx="5458968" cy="0"/>
+          </a:xfrm>
+          <a:prstGeom prst="line">
+            <a:avLst/>
+          </a:prstGeom>
+          <a:noFill/>
+          <a:ln w="9525">
             <a:solidFill>
-              <a:srgbClr val="C2A35B"/>
+              <a:srgbClr val="D9D2C4"/>
             </a:solidFill>
             <a:prstDash val="solid"/>
           </a:ln>
@@ -1270,14 +2057,14 @@
       </p:sp>
       <p:sp>
         <p:nvSpPr>
-          <p:cNvPr id="13" name="Text 11"/>
-          <p:cNvSpPr/>
-          <p:nvPr/>
-        </p:nvSpPr>
-        <p:spPr>
-          <a:xfrm>
-            <a:off x="777240" y="5349240"/>
-            <a:ext cx="6126480" cy="347472"/>
+          <p:cNvPr id="36" name="Text 34"/>
+          <p:cNvSpPr/>
+          <p:nvPr/>
+        </p:nvSpPr>
+        <p:spPr>
+          <a:xfrm>
+            <a:off x="777240" y="7690104"/>
+            <a:ext cx="457200" cy="457200"/>
           </a:xfrm>
           <a:prstGeom prst="rect">
             <a:avLst/>
@@ -1293,15 +2080,175 @@
               <a:buNone/>
             </a:pPr>
             <a:r>
-              <a:rPr lang="en-US" sz="1050" dirty="0">
-                <a:solidFill>
-                  <a:srgbClr val="FFFFFF"/>
+              <a:rPr lang="en-US" sz="2100" b="1" dirty="0">
+                <a:solidFill>
+                  <a:srgbClr val="B8985A"/>
+                </a:solidFill>
+                <a:latin typeface="Cambria" pitchFamily="34" charset="0"/>
+                <a:ea typeface="Cambria" pitchFamily="34" charset="-122"/>
+                <a:cs typeface="Cambria" pitchFamily="34" charset="-120"/>
+              </a:rPr>
+              <a:t>7</a:t>
+            </a:r>
+            <a:endParaRPr lang="en-US" sz="2100" dirty="0"/>
+          </a:p>
+        </p:txBody>
+      </p:sp>
+      <p:sp>
+        <p:nvSpPr>
+          <p:cNvPr id="37" name="Text 35"/>
+          <p:cNvSpPr/>
+          <p:nvPr/>
+        </p:nvSpPr>
+        <p:spPr>
+          <a:xfrm>
+            <a:off x="1325880" y="7744968"/>
+            <a:ext cx="5458968" cy="475488"/>
+          </a:xfrm>
+          <a:prstGeom prst="rect">
+            <a:avLst/>
+          </a:prstGeom>
+          <a:noFill/>
+          <a:ln/>
+        </p:spPr>
+        <p:txBody>
+          <a:bodyPr wrap="square" lIns="0" tIns="0" rIns="0" bIns="0" rtlCol="0" anchor="ctr"/>
+          <a:lstStyle/>
+          <a:p>
+            <a:pPr indent="0" marL="0">
+              <a:lnSpc>
+                <a:spcPts val="1350"/>
+              </a:lnSpc>
+              <a:buNone/>
+            </a:pPr>
+            <a:r>
+              <a:rPr lang="en-US" sz="1150" b="1" dirty="0">
+                <a:solidFill>
+                  <a:srgbClr val="1B2A4A"/>
+                </a:solidFill>
+                <a:latin typeface="Cambria" pitchFamily="34" charset="0"/>
+                <a:ea typeface="Cambria" pitchFamily="34" charset="-122"/>
+                <a:cs typeface="Cambria" pitchFamily="34" charset="-120"/>
+              </a:rPr>
+              <a:t>Conselheiro de IA  —  </a:t>
+            </a:r>
+            <a:pPr indent="0" marL="0">
+              <a:lnSpc>
+                <a:spcPts val="1350"/>
+              </a:lnSpc>
+              <a:buNone/>
+            </a:pPr>
+            <a:r>
+              <a:rPr lang="en-US" sz="980" dirty="0">
+                <a:solidFill>
+                  <a:srgbClr val="232B3A"/>
                 </a:solidFill>
                 <a:latin typeface="Calibri" pitchFamily="34" charset="0"/>
                 <a:ea typeface="Calibri" pitchFamily="34" charset="-122"/>
                 <a:cs typeface="Calibri" pitchFamily="34" charset="-120"/>
               </a:rPr>
-              <a:t>Construção e implantação — agentes sob medida, em produção</a:t>
+              <a:t>A cadeira de estrategista do seu lado da mesa — também para quem já tem IA rodando.</a:t>
+            </a:r>
+            <a:endParaRPr lang="en-US" sz="1150" dirty="0"/>
+          </a:p>
+        </p:txBody>
+      </p:sp>
+      <p:sp>
+        <p:nvSpPr>
+          <p:cNvPr id="38" name="Shape 36"/>
+          <p:cNvSpPr/>
+          <p:nvPr/>
+        </p:nvSpPr>
+        <p:spPr>
+          <a:xfrm>
+            <a:off x="777240" y="8458200"/>
+            <a:ext cx="6007608" cy="914400"/>
+          </a:xfrm>
+          <a:prstGeom prst="rect">
+            <a:avLst/>
+          </a:prstGeom>
+          <a:solidFill>
+            <a:srgbClr val="F7F4EE"/>
+          </a:solidFill>
+          <a:ln/>
+        </p:spPr>
+      </p:sp>
+      <p:sp>
+        <p:nvSpPr>
+          <p:cNvPr id="39" name="Text 37"/>
+          <p:cNvSpPr/>
+          <p:nvPr/>
+        </p:nvSpPr>
+        <p:spPr>
+          <a:xfrm>
+            <a:off x="1051560" y="8577072"/>
+            <a:ext cx="5458968" cy="219456"/>
+          </a:xfrm>
+          <a:prstGeom prst="rect">
+            <a:avLst/>
+          </a:prstGeom>
+          <a:noFill/>
+          <a:ln/>
+        </p:spPr>
+        <p:txBody>
+          <a:bodyPr wrap="square" lIns="0" tIns="0" rIns="0" bIns="0" rtlCol="0" anchor="ctr"/>
+          <a:lstStyle/>
+          <a:p>
+            <a:pPr indent="0" marL="0">
+              <a:buNone/>
+            </a:pPr>
+            <a:r>
+              <a:rPr lang="en-US" sz="800" b="1" spc="200" kern="0" dirty="0">
+                <a:solidFill>
+                  <a:srgbClr val="B8985A"/>
+                </a:solidFill>
+                <a:latin typeface="Calibri" pitchFamily="34" charset="0"/>
+                <a:ea typeface="Calibri" pitchFamily="34" charset="-122"/>
+                <a:cs typeface="Calibri" pitchFamily="34" charset="-120"/>
+              </a:rPr>
+              <a:t>A mentalidade que instalamos em cada colaborador:</a:t>
+            </a:r>
+            <a:endParaRPr lang="en-US" sz="800" dirty="0"/>
+          </a:p>
+        </p:txBody>
+      </p:sp>
+      <p:sp>
+        <p:nvSpPr>
+          <p:cNvPr id="40" name="Text 38"/>
+          <p:cNvSpPr/>
+          <p:nvPr/>
+        </p:nvSpPr>
+        <p:spPr>
+          <a:xfrm>
+            <a:off x="1051560" y="8814816"/>
+            <a:ext cx="5458968" cy="475488"/>
+          </a:xfrm>
+          <a:prstGeom prst="rect">
+            <a:avLst/>
+          </a:prstGeom>
+          <a:noFill/>
+          <a:ln/>
+        </p:spPr>
+        <p:txBody>
+          <a:bodyPr wrap="square" lIns="0" tIns="0" rIns="0" bIns="0" rtlCol="0" anchor="ctr"/>
+          <a:lstStyle/>
+          <a:p>
+            <a:pPr indent="0" marL="0">
+              <a:lnSpc>
+                <a:spcPts val="1450"/>
+              </a:lnSpc>
+              <a:buNone/>
+            </a:pPr>
+            <a:r>
+              <a:rPr lang="en-US" sz="1050" i="1" dirty="0">
+                <a:solidFill>
+                  <a:srgbClr val="1B2A4A"/>
+                </a:solidFill>
+                <a:latin typeface="Cambria" pitchFamily="34" charset="0"/>
+                <a:ea typeface="Cambria" pitchFamily="34" charset="-122"/>
+                <a:cs typeface="Cambria" pitchFamily="34" charset="-120"/>
+              </a:rPr>
+              <a:t>O que eu posso parar de fazer, porque a IA agora faz? · O que posso começar a fazer, porque a IA agora permite? · O que só eu faço — e devo fazer ainda melhor?</a:t>
             </a:r>
             <a:endParaRPr lang="en-US" sz="1050" dirty="0"/>
           </a:p>
@@ -1309,26 +2256,114 @@
       </p:sp>
       <p:sp>
         <p:nvSpPr>
-          <p:cNvPr id="14" name="Shape 12"/>
-          <p:cNvSpPr/>
-          <p:nvPr/>
-        </p:nvSpPr>
-        <p:spPr>
-          <a:xfrm>
-            <a:off x="548640" y="5879592"/>
-            <a:ext cx="6492240" cy="475488"/>
-          </a:xfrm>
-          <a:prstGeom prst="roundRect">
-            <a:avLst>
-              <a:gd name="adj" fmla="val 19231"/>
-            </a:avLst>
-          </a:prstGeom>
-          <a:solidFill>
-            <a:srgbClr val="24365E"/>
-          </a:solidFill>
-          <a:ln w="6350">
+          <p:cNvPr id="41" name="Text 39"/>
+          <p:cNvSpPr/>
+          <p:nvPr/>
+        </p:nvSpPr>
+        <p:spPr>
+          <a:xfrm>
+            <a:off x="777240" y="9509760"/>
+            <a:ext cx="6007608" cy="228600"/>
+          </a:xfrm>
+          <a:prstGeom prst="rect">
+            <a:avLst/>
+          </a:prstGeom>
+          <a:noFill/>
+          <a:ln/>
+        </p:spPr>
+        <p:txBody>
+          <a:bodyPr wrap="square" lIns="0" tIns="0" rIns="0" bIns="0" rtlCol="0" anchor="ctr"/>
+          <a:lstStyle/>
+          <a:p>
+            <a:pPr indent="0" marL="0">
+              <a:buNone/>
+            </a:pPr>
+            <a:r>
+              <a:rPr lang="en-US" sz="750" b="1" spc="200" kern="0" dirty="0">
+                <a:solidFill>
+                  <a:srgbClr val="B8985A"/>
+                </a:solidFill>
+                <a:latin typeface="Calibri" pitchFamily="34" charset="0"/>
+                <a:ea typeface="Calibri" pitchFamily="34" charset="-122"/>
+                <a:cs typeface="Calibri" pitchFamily="34" charset="-120"/>
+              </a:rPr>
+              <a:t>PARCEIROS OFICIAIS   </a:t>
+            </a:r>
+            <a:pPr indent="0" marL="0">
+              <a:buNone/>
+            </a:pPr>
+            <a:r>
+              <a:rPr lang="en-US" sz="950" dirty="0">
+                <a:solidFill>
+                  <a:srgbClr val="232B3A"/>
+                </a:solidFill>
+                <a:latin typeface="Calibri" pitchFamily="34" charset="0"/>
+                <a:ea typeface="Calibri" pitchFamily="34" charset="-122"/>
+                <a:cs typeface="Calibri" pitchFamily="34" charset="-120"/>
+              </a:rPr>
+              <a:t>Microsoft e CrewAI</a:t>
+            </a:r>
+            <a:endParaRPr lang="en-US" sz="750" dirty="0"/>
+          </a:p>
+        </p:txBody>
+      </p:sp>
+      <p:sp>
+        <p:nvSpPr>
+          <p:cNvPr id="42" name="Text 40"/>
+          <p:cNvSpPr/>
+          <p:nvPr/>
+        </p:nvSpPr>
+        <p:spPr>
+          <a:xfrm>
+            <a:off x="777240" y="9765792"/>
+            <a:ext cx="6007608" cy="274320"/>
+          </a:xfrm>
+          <a:prstGeom prst="rect">
+            <a:avLst/>
+          </a:prstGeom>
+          <a:noFill/>
+          <a:ln/>
+        </p:spPr>
+        <p:txBody>
+          <a:bodyPr wrap="square" lIns="0" tIns="0" rIns="0" bIns="0" rtlCol="0" anchor="ctr"/>
+          <a:lstStyle/>
+          <a:p>
+            <a:pPr indent="0" marL="0">
+              <a:buNone/>
+            </a:pPr>
+            <a:r>
+              <a:rPr lang="en-US" sz="950" dirty="0">
+                <a:solidFill>
+                  <a:srgbClr val="232B3A"/>
+                </a:solidFill>
+                <a:latin typeface="Calibri" pitchFamily="34" charset="0"/>
+                <a:ea typeface="Calibri" pitchFamily="34" charset="-122"/>
+                <a:cs typeface="Calibri" pitchFamily="34" charset="-120"/>
+              </a:rPr>
+              <a:t>O primeiro passo não custa nada: o seu Mapa de Vazamento, em 48 horas.  ·  comercial@abbaservices.com.br</a:t>
+            </a:r>
+            <a:endParaRPr lang="en-US" sz="950" dirty="0"/>
+          </a:p>
+        </p:txBody>
+      </p:sp>
+      <p:sp>
+        <p:nvSpPr>
+          <p:cNvPr id="43" name="Shape 41"/>
+          <p:cNvSpPr/>
+          <p:nvPr/>
+        </p:nvSpPr>
+        <p:spPr>
+          <a:xfrm>
+            <a:off x="777240" y="10195560"/>
+            <a:ext cx="6007608" cy="0"/>
+          </a:xfrm>
+          <a:prstGeom prst="line">
+            <a:avLst/>
+          </a:prstGeom>
+          <a:noFill/>
+          <a:ln w="9525">
             <a:solidFill>
-              <a:srgbClr val="C2A35B"/>
+              <a:srgbClr val="D9D2C4"/>
             </a:solidFill>
             <a:prstDash val="solid"/>
           </a:ln>
@@ -1336,14 +2371,14 @@
       </p:sp>
       <p:sp>
         <p:nvSpPr>
-          <p:cNvPr id="15" name="Text 13"/>
-          <p:cNvSpPr/>
-          <p:nvPr/>
-        </p:nvSpPr>
-        <p:spPr>
-          <a:xfrm>
-            <a:off x="777240" y="5952744"/>
-            <a:ext cx="6126480" cy="347472"/>
+          <p:cNvPr id="44" name="Text 42"/>
+          <p:cNvSpPr/>
+          <p:nvPr/>
+        </p:nvSpPr>
+        <p:spPr>
+          <a:xfrm>
+            <a:off x="777240" y="10277856"/>
+            <a:ext cx="4389120" cy="201168"/>
           </a:xfrm>
           <a:prstGeom prst="rect">
             <a:avLst/>
@@ -1359,57 +2394,30 @@
               <a:buNone/>
             </a:pPr>
             <a:r>
-              <a:rPr lang="en-US" sz="1050" dirty="0">
-                <a:solidFill>
-                  <a:srgbClr val="FFFFFF"/>
+              <a:rPr lang="en-US" sz="750" spc="220" kern="0" dirty="0">
+                <a:solidFill>
+                  <a:srgbClr val="5A6472"/>
                 </a:solidFill>
                 <a:latin typeface="Calibri" pitchFamily="34" charset="0"/>
                 <a:ea typeface="Calibri" pitchFamily="34" charset="-122"/>
                 <a:cs typeface="Calibri" pitchFamily="34" charset="-120"/>
               </a:rPr>
-              <a:t>Treinamento + ABBA Portal — todos os níveis, plataforma própria + presencial</a:t>
-            </a:r>
-            <a:endParaRPr lang="en-US" sz="1050" dirty="0"/>
-          </a:p>
-        </p:txBody>
-      </p:sp>
-      <p:sp>
-        <p:nvSpPr>
-          <p:cNvPr id="16" name="Shape 14"/>
-          <p:cNvSpPr/>
-          <p:nvPr/>
-        </p:nvSpPr>
-        <p:spPr>
-          <a:xfrm>
-            <a:off x="548640" y="6483096"/>
-            <a:ext cx="6492240" cy="475488"/>
-          </a:xfrm>
-          <a:prstGeom prst="roundRect">
-            <a:avLst>
-              <a:gd name="adj" fmla="val 19231"/>
-            </a:avLst>
-          </a:prstGeom>
-          <a:solidFill>
-            <a:srgbClr val="24365E"/>
-          </a:solidFill>
-          <a:ln w="6350">
-            <a:solidFill>
-              <a:srgbClr val="C2A35B"/>
-            </a:solidFill>
-            <a:prstDash val="solid"/>
-          </a:ln>
-        </p:spPr>
-      </p:sp>
-      <p:sp>
-        <p:nvSpPr>
-          <p:cNvPr id="17" name="Text 15"/>
-          <p:cNvSpPr/>
-          <p:nvPr/>
-        </p:nvSpPr>
-        <p:spPr>
-          <a:xfrm>
-            <a:off x="777240" y="6556248"/>
-            <a:ext cx="6126480" cy="347472"/>
+              <a:t>ABBA — CONSULTORIA DE INTELIGÊNCIA ARTIFICIAL</a:t>
+            </a:r>
+            <a:endParaRPr lang="en-US" sz="750" dirty="0"/>
+          </a:p>
+        </p:txBody>
+      </p:sp>
+      <p:sp>
+        <p:nvSpPr>
+          <p:cNvPr id="45" name="Text 43"/>
+          <p:cNvSpPr/>
+          <p:nvPr/>
+        </p:nvSpPr>
+        <p:spPr>
+          <a:xfrm>
+            <a:off x="4773168" y="10277856"/>
+            <a:ext cx="2011680" cy="201168"/>
           </a:xfrm>
           <a:prstGeom prst="rect">
             <a:avLst/>
@@ -1421,304 +2429,21 @@
           <a:bodyPr wrap="square" lIns="0" tIns="0" rIns="0" bIns="0" rtlCol="0" anchor="ctr"/>
           <a:lstStyle/>
           <a:p>
-            <a:pPr indent="0" marL="0">
-              <a:buNone/>
-            </a:pPr>
-            <a:r>
-              <a:rPr lang="en-US" sz="1050" dirty="0">
-                <a:solidFill>
-                  <a:srgbClr val="FFFFFF"/>
+            <a:pPr algn="r" indent="0" marL="0">
+              <a:buNone/>
+            </a:pPr>
+            <a:r>
+              <a:rPr lang="en-US" sz="750" spc="220" kern="0" dirty="0">
+                <a:solidFill>
+                  <a:srgbClr val="5A6472"/>
                 </a:solidFill>
                 <a:latin typeface="Calibri" pitchFamily="34" charset="0"/>
                 <a:ea typeface="Calibri" pitchFamily="34" charset="-122"/>
                 <a:cs typeface="Calibri" pitchFamily="34" charset="-120"/>
               </a:rPr>
-              <a:t>Sistemas gerenciados — operação com presença e resultado medido</a:t>
-            </a:r>
-            <a:endParaRPr lang="en-US" sz="1050" dirty="0"/>
-          </a:p>
-        </p:txBody>
-      </p:sp>
-      <p:sp>
-        <p:nvSpPr>
-          <p:cNvPr id="18" name="Shape 16"/>
-          <p:cNvSpPr/>
-          <p:nvPr/>
-        </p:nvSpPr>
-        <p:spPr>
-          <a:xfrm>
-            <a:off x="548640" y="7086600"/>
-            <a:ext cx="6492240" cy="475488"/>
-          </a:xfrm>
-          <a:prstGeom prst="roundRect">
-            <a:avLst>
-              <a:gd name="adj" fmla="val 19231"/>
-            </a:avLst>
-          </a:prstGeom>
-          <a:solidFill>
-            <a:srgbClr val="24365E"/>
-          </a:solidFill>
-          <a:ln w="6350">
-            <a:solidFill>
-              <a:srgbClr val="C2A35B"/>
-            </a:solidFill>
-            <a:prstDash val="solid"/>
-          </a:ln>
-        </p:spPr>
-      </p:sp>
-      <p:sp>
-        <p:nvSpPr>
-          <p:cNvPr id="19" name="Text 17"/>
-          <p:cNvSpPr/>
-          <p:nvPr/>
-        </p:nvSpPr>
-        <p:spPr>
-          <a:xfrm>
-            <a:off x="777240" y="7159752"/>
-            <a:ext cx="6126480" cy="347472"/>
-          </a:xfrm>
-          <a:prstGeom prst="rect">
-            <a:avLst/>
-          </a:prstGeom>
-          <a:noFill/>
-          <a:ln/>
-        </p:spPr>
-        <p:txBody>
-          <a:bodyPr wrap="square" lIns="0" tIns="0" rIns="0" bIns="0" rtlCol="0" anchor="ctr"/>
-          <a:lstStyle/>
-          <a:p>
-            <a:pPr indent="0" marL="0">
-              <a:buNone/>
-            </a:pPr>
-            <a:r>
-              <a:rPr lang="en-US" sz="1050" dirty="0">
-                <a:solidFill>
-                  <a:srgbClr val="FFFFFF"/>
-                </a:solidFill>
-                <a:latin typeface="Calibri" pitchFamily="34" charset="0"/>
-                <a:ea typeface="Calibri" pitchFamily="34" charset="-122"/>
-                <a:cs typeface="Calibri" pitchFamily="34" charset="-120"/>
-              </a:rPr>
-              <a:t>Conselheiro de IA — a cadeira de estrategista do seu lado da mesa</a:t>
-            </a:r>
-            <a:endParaRPr lang="en-US" sz="1050" dirty="0"/>
-          </a:p>
-        </p:txBody>
-      </p:sp>
-      <p:sp>
-        <p:nvSpPr>
-          <p:cNvPr id="20" name="Shape 18"/>
-          <p:cNvSpPr/>
-          <p:nvPr/>
-        </p:nvSpPr>
-        <p:spPr>
-          <a:xfrm>
-            <a:off x="548640" y="7863840"/>
-            <a:ext cx="6492240" cy="1417320"/>
-          </a:xfrm>
-          <a:prstGeom prst="roundRect">
-            <a:avLst>
-              <a:gd name="adj" fmla="val 3871"/>
-            </a:avLst>
-          </a:prstGeom>
-          <a:solidFill>
-            <a:srgbClr val="24365E"/>
-          </a:solidFill>
-          <a:ln/>
-        </p:spPr>
-      </p:sp>
-      <p:sp>
-        <p:nvSpPr>
-          <p:cNvPr id="21" name="Text 19"/>
-          <p:cNvSpPr/>
-          <p:nvPr/>
-        </p:nvSpPr>
-        <p:spPr>
-          <a:xfrm>
-            <a:off x="777240" y="8001000"/>
-            <a:ext cx="6035040" cy="274320"/>
-          </a:xfrm>
-          <a:prstGeom prst="rect">
-            <a:avLst/>
-          </a:prstGeom>
-          <a:noFill/>
-          <a:ln/>
-        </p:spPr>
-        <p:txBody>
-          <a:bodyPr wrap="square" lIns="0" tIns="0" rIns="0" bIns="0" rtlCol="0" anchor="ctr"/>
-          <a:lstStyle/>
-          <a:p>
-            <a:pPr indent="0" marL="0">
-              <a:buNone/>
-            </a:pPr>
-            <a:r>
-              <a:rPr lang="en-US" sz="1050" b="1" dirty="0">
-                <a:solidFill>
-                  <a:srgbClr val="C2A35B"/>
-                </a:solidFill>
-                <a:latin typeface="Calibri" pitchFamily="34" charset="0"/>
-                <a:ea typeface="Calibri" pitchFamily="34" charset="-122"/>
-                <a:cs typeface="Calibri" pitchFamily="34" charset="-120"/>
-              </a:rPr>
-              <a:t>A mentalidade que instalamos em cada colaborador:</a:t>
-            </a:r>
-            <a:endParaRPr lang="en-US" sz="1050" dirty="0"/>
-          </a:p>
-        </p:txBody>
-      </p:sp>
-      <p:sp>
-        <p:nvSpPr>
-          <p:cNvPr id="22" name="Text 20"/>
-          <p:cNvSpPr/>
-          <p:nvPr/>
-        </p:nvSpPr>
-        <p:spPr>
-          <a:xfrm>
-            <a:off x="777240" y="8321040"/>
-            <a:ext cx="6035040" cy="777240"/>
-          </a:xfrm>
-          <a:prstGeom prst="rect">
-            <a:avLst/>
-          </a:prstGeom>
-          <a:noFill/>
-          <a:ln/>
-        </p:spPr>
-        <p:txBody>
-          <a:bodyPr wrap="square" lIns="0" tIns="0" rIns="0" bIns="0" rtlCol="0" anchor="ctr"/>
-          <a:lstStyle/>
-          <a:p>
-            <a:pPr indent="0" marL="0">
-              <a:buNone/>
-            </a:pPr>
-            <a:r>
-              <a:rPr lang="en-US" sz="1050" dirty="0">
-                <a:solidFill>
-                  <a:srgbClr val="FFFFFF"/>
-                </a:solidFill>
-                <a:latin typeface="Calibri" pitchFamily="34" charset="0"/>
-                <a:ea typeface="Calibri" pitchFamily="34" charset="-122"/>
-                <a:cs typeface="Calibri" pitchFamily="34" charset="-120"/>
-              </a:rPr>
-              <a:t>O que eu posso PARAR de fazer, porque a IA agora faz?  ·  O que posso COMEÇAR a fazer, porque a IA agora permite?  ·  O que SÓ EU faço — e devo fazer ainda melhor?</a:t>
-            </a:r>
-            <a:endParaRPr lang="en-US" sz="1050" dirty="0"/>
-          </a:p>
-        </p:txBody>
-      </p:sp>
-      <p:sp>
-        <p:nvSpPr>
-          <p:cNvPr id="23" name="Text 21"/>
-          <p:cNvSpPr/>
-          <p:nvPr/>
-        </p:nvSpPr>
-        <p:spPr>
-          <a:xfrm>
-            <a:off x="548640" y="9464040"/>
-            <a:ext cx="6492240" cy="274320"/>
-          </a:xfrm>
-          <a:prstGeom prst="rect">
-            <a:avLst/>
-          </a:prstGeom>
-          <a:noFill/>
-          <a:ln/>
-        </p:spPr>
-        <p:txBody>
-          <a:bodyPr wrap="square" lIns="0" tIns="0" rIns="0" bIns="0" rtlCol="0" anchor="ctr"/>
-          <a:lstStyle/>
-          <a:p>
-            <a:pPr indent="0" marL="0">
-              <a:buNone/>
-            </a:pPr>
-            <a:r>
-              <a:rPr lang="en-US" sz="1050" b="1" dirty="0">
-                <a:solidFill>
-                  <a:srgbClr val="C2A35B"/>
-                </a:solidFill>
-                <a:latin typeface="Calibri" pitchFamily="34" charset="0"/>
-                <a:ea typeface="Calibri" pitchFamily="34" charset="-122"/>
-                <a:cs typeface="Calibri" pitchFamily="34" charset="-120"/>
-              </a:rPr>
-              <a:t>Parceiros oficiais: Microsoft · CrewAI</a:t>
-            </a:r>
-            <a:endParaRPr lang="en-US" sz="1050" dirty="0"/>
-          </a:p>
-        </p:txBody>
-      </p:sp>
-      <p:sp>
-        <p:nvSpPr>
-          <p:cNvPr id="24" name="Text 22"/>
-          <p:cNvSpPr/>
-          <p:nvPr/>
-        </p:nvSpPr>
-        <p:spPr>
-          <a:xfrm>
-            <a:off x="548640" y="9765792"/>
-            <a:ext cx="6492240" cy="365760"/>
-          </a:xfrm>
-          <a:prstGeom prst="rect">
-            <a:avLst/>
-          </a:prstGeom>
-          <a:noFill/>
-          <a:ln/>
-        </p:spPr>
-        <p:txBody>
-          <a:bodyPr wrap="square" lIns="0" tIns="0" rIns="0" bIns="0" rtlCol="0" anchor="ctr"/>
-          <a:lstStyle/>
-          <a:p>
-            <a:pPr indent="0" marL="0">
-              <a:buNone/>
-            </a:pPr>
-            <a:r>
-              <a:rPr lang="en-US" sz="1000" dirty="0">
-                <a:solidFill>
-                  <a:srgbClr val="C9D2E4"/>
-                </a:solidFill>
-                <a:latin typeface="Calibri" pitchFamily="34" charset="0"/>
-                <a:ea typeface="Calibri" pitchFamily="34" charset="-122"/>
-                <a:cs typeface="Calibri" pitchFamily="34" charset="-120"/>
-              </a:rPr>
-              <a:t>Primeiro passo, sem custo: o Mapa de Vazamento — uma estimativa em reais do que pode estar vazando na sua operação, em 48h.</a:t>
-            </a:r>
-            <a:endParaRPr lang="en-US" sz="1000" dirty="0"/>
-          </a:p>
-        </p:txBody>
-      </p:sp>
-      <p:sp>
-        <p:nvSpPr>
-          <p:cNvPr id="25" name="Text 23"/>
-          <p:cNvSpPr/>
-          <p:nvPr/>
-        </p:nvSpPr>
-        <p:spPr>
-          <a:xfrm>
-            <a:off x="548640" y="10351008"/>
-            <a:ext cx="6583680" cy="228600"/>
-          </a:xfrm>
-          <a:prstGeom prst="rect">
-            <a:avLst/>
-          </a:prstGeom>
-          <a:noFill/>
-          <a:ln/>
-        </p:spPr>
-        <p:txBody>
-          <a:bodyPr wrap="square" lIns="0" tIns="0" rIns="0" bIns="0" rtlCol="0" anchor="ctr"/>
-          <a:lstStyle/>
-          <a:p>
-            <a:pPr indent="0" marL="0">
-              <a:buNone/>
-            </a:pPr>
-            <a:r>
-              <a:rPr lang="en-US" sz="850" dirty="0">
-                <a:solidFill>
-                  <a:srgbClr val="8FA0BF"/>
-                </a:solidFill>
-                <a:latin typeface="Calibri" pitchFamily="34" charset="0"/>
-                <a:ea typeface="Calibri" pitchFamily="34" charset="-122"/>
-                <a:cs typeface="Calibri" pitchFamily="34" charset="-120"/>
-              </a:rPr>
-              <a:t>ABBA Consultoria de IA · comercial@abbaservices.com.br · abbaservices.com.br</a:t>
-            </a:r>
-            <a:endParaRPr lang="en-US" sz="850" dirty="0"/>
+              <a:t>ABBASERVICES.COM.BR</a:t>
+            </a:r>
+            <a:endParaRPr lang="en-US" sz="750" dirty="0"/>
           </a:p>
         </p:txBody>
       </p:sp>

</xml_diff>